<commit_message>
part 2 of presentation added, wiht results from hands on exercise
</commit_message>
<xml_diff>
--- a/GSoC – GreenMetaData Project.pptx
+++ b/GSoC – GreenMetaData Project.pptx
@@ -10,8 +10,10 @@
     <p:sldId id="258" r:id="rId4"/>
     <p:sldId id="260" r:id="rId5"/>
     <p:sldId id="259" r:id="rId6"/>
-    <p:sldId id="261" r:id="rId7"/>
-    <p:sldId id="262" r:id="rId8"/>
+    <p:sldId id="262" r:id="rId7"/>
+    <p:sldId id="263" r:id="rId8"/>
+    <p:sldId id="264" r:id="rId9"/>
+    <p:sldId id="265" r:id="rId10"/>
   </p:sldIdLst>
   <p:sldSz cx="12192000" cy="6858000"/>
   <p:notesSz cx="6858000" cy="9144000"/>
@@ -5666,7 +5668,7 @@
         <p:cNvPr id="1" name="">
           <a:extLst>
             <a:ext uri="{FF2B5EF4-FFF2-40B4-BE49-F238E27FC236}">
-              <a16:creationId xmlns:a16="http://schemas.microsoft.com/office/drawing/2014/main" id="{FA91E781-6D71-C661-3369-1FB6E6FA5CBE}"/>
+              <a16:creationId xmlns:a16="http://schemas.microsoft.com/office/drawing/2014/main" id="{C17CB6B3-619A-85FD-F2B8-E293156F2069}"/>
             </a:ext>
           </a:extLst>
         </p:cNvPr>
@@ -5686,7 +5688,7 @@
           <p:cNvPr id="2" name="Title 1">
             <a:extLst>
               <a:ext uri="{FF2B5EF4-FFF2-40B4-BE49-F238E27FC236}">
-                <a16:creationId xmlns:a16="http://schemas.microsoft.com/office/drawing/2014/main" id="{FC2155AB-F1F6-7CF4-57DA-D98894EB171B}"/>
+                <a16:creationId xmlns:a16="http://schemas.microsoft.com/office/drawing/2014/main" id="{B8CCAF32-1E81-F4E6-2BA1-E7B892654C69}"/>
               </a:ext>
             </a:extLst>
           </p:cNvPr>
@@ -5722,155 +5724,161 @@
                 <a:ea typeface="+mj-ea"/>
                 <a:cs typeface="+mj-cs"/>
               </a:rPr>
-              <a:t>Big Picture Impacts</a:t>
-            </a:r>
-          </a:p>
-        </p:txBody>
-      </p:sp>
-      <p:sp>
-        <p:nvSpPr>
-          <p:cNvPr id="4" name="Title 1">
-            <a:extLst>
-              <a:ext uri="{FF2B5EF4-FFF2-40B4-BE49-F238E27FC236}">
-                <a16:creationId xmlns:a16="http://schemas.microsoft.com/office/drawing/2014/main" id="{B745C0E6-8CAA-E3ED-99DB-90B15AE6D373}"/>
-              </a:ext>
-            </a:extLst>
-          </p:cNvPr>
-          <p:cNvSpPr txBox="1">
-            <a:spLocks/>
-          </p:cNvSpPr>
+              <a:t>Part 2: Hands-On Exercise</a:t>
+            </a:r>
+          </a:p>
+        </p:txBody>
+      </p:sp>
+      <p:sp>
+        <p:nvSpPr>
+          <p:cNvPr id="3" name="Rectangle: Rounded Corners 2">
+            <a:extLst>
+              <a:ext uri="{FF2B5EF4-FFF2-40B4-BE49-F238E27FC236}">
+                <a16:creationId xmlns:a16="http://schemas.microsoft.com/office/drawing/2014/main" id="{37DA2A87-6070-449E-B12B-7CE51FA8B29A}"/>
+              </a:ext>
+            </a:extLst>
+          </p:cNvPr>
+          <p:cNvSpPr/>
           <p:nvPr/>
         </p:nvSpPr>
         <p:spPr>
           <a:xfrm>
-            <a:off x="816797" y="2782581"/>
-            <a:ext cx="10558405" cy="1059999"/>
+            <a:off x="1137920" y="1971040"/>
+            <a:ext cx="4307840" cy="4175760"/>
           </a:xfrm>
-          <a:prstGeom prst="rect">
+          <a:prstGeom prst="roundRect">
             <a:avLst/>
           </a:prstGeom>
+          <a:solidFill>
+            <a:schemeClr val="accent6">
+              <a:lumMod val="50000"/>
+            </a:schemeClr>
+          </a:solidFill>
+          <a:ln>
+            <a:noFill/>
+          </a:ln>
         </p:spPr>
-        <p:txBody>
-          <a:bodyPr vert="horz" lIns="91440" tIns="45720" rIns="91440" bIns="45720" rtlCol="0" anchor="b">
-            <a:normAutofit fontScale="40000" lnSpcReduction="20000"/>
-          </a:bodyPr>
-          <a:lstStyle>
-            <a:lvl1pPr algn="l" defTabSz="914400" rtl="0" eaLnBrk="1" latinLnBrk="0" hangingPunct="1">
-              <a:lnSpc>
-                <a:spcPct val="90000"/>
-              </a:lnSpc>
-              <a:spcBef>
-                <a:spcPct val="0"/>
-              </a:spcBef>
-              <a:buNone/>
-              <a:defRPr sz="4400" kern="1200">
-                <a:solidFill>
-                  <a:schemeClr val="tx1"/>
-                </a:solidFill>
-                <a:latin typeface="+mj-lt"/>
-                <a:ea typeface="+mj-ea"/>
-                <a:cs typeface="+mj-cs"/>
-              </a:defRPr>
-            </a:lvl1pPr>
-          </a:lstStyle>
-          <a:p>
-            <a:pPr marL="0" marR="0" lvl="0" indent="0" algn="l" defTabSz="914400" rtl="0" eaLnBrk="1" fontAlgn="auto" latinLnBrk="0" hangingPunct="1">
-              <a:lnSpc>
-                <a:spcPct val="90000"/>
-              </a:lnSpc>
-              <a:spcBef>
-                <a:spcPct val="0"/>
-              </a:spcBef>
-              <a:spcAft>
-                <a:spcPts val="0"/>
-              </a:spcAft>
-              <a:buClrTx/>
-              <a:buSzTx/>
-              <a:buFontTx/>
-              <a:buNone/>
-              <a:tabLst/>
-              <a:defRPr/>
-            </a:pPr>
-            <a:r>
-              <a:rPr kumimoji="0" lang="en-US" sz="4800" b="0" i="0" u="none" strike="noStrike" kern="1200" cap="none" spc="0" normalizeH="0" baseline="0" noProof="0" dirty="0">
-                <a:ln>
-                  <a:noFill/>
-                </a:ln>
-                <a:solidFill>
-                  <a:prstClr val="white"/>
-                </a:solidFill>
-                <a:effectLst/>
-                <a:uLnTx/>
-                <a:uFillTx/>
-                <a:latin typeface="Aptos Display" panose="02110004020202020204"/>
-                <a:ea typeface="+mj-ea"/>
-                <a:cs typeface="+mj-cs"/>
-              </a:rPr>
-              <a:t>Big picture impact: cultural shift in research towards greener attitudes and practices.</a:t>
-            </a:r>
-          </a:p>
-          <a:p>
-            <a:pPr marL="0" marR="0" lvl="0" indent="0" algn="l" defTabSz="914400" rtl="0" eaLnBrk="1" fontAlgn="auto" latinLnBrk="0" hangingPunct="1">
-              <a:lnSpc>
-                <a:spcPct val="90000"/>
-              </a:lnSpc>
-              <a:spcBef>
-                <a:spcPct val="0"/>
-              </a:spcBef>
-              <a:spcAft>
-                <a:spcPts val="0"/>
-              </a:spcAft>
-              <a:buClrTx/>
-              <a:buSzTx/>
-              <a:buFontTx/>
-              <a:buNone/>
-              <a:tabLst/>
-              <a:defRPr/>
-            </a:pPr>
-            <a:r>
-              <a:rPr lang="en-US" sz="4800" dirty="0">
-                <a:solidFill>
-                  <a:prstClr val="white"/>
-                </a:solidFill>
-                <a:latin typeface="Aptos Display" panose="02110004020202020204"/>
-              </a:rPr>
-              <a:t>CO2 budgeting (cost benefit analysis including emissions, predicted emissions for funding applications)</a:t>
-            </a:r>
-          </a:p>
-          <a:p>
-            <a:pPr marL="0" marR="0" lvl="0" indent="0" algn="l" defTabSz="914400" rtl="0" eaLnBrk="1" fontAlgn="auto" latinLnBrk="0" hangingPunct="1">
-              <a:lnSpc>
-                <a:spcPct val="90000"/>
-              </a:lnSpc>
-              <a:spcBef>
-                <a:spcPct val="0"/>
-              </a:spcBef>
-              <a:spcAft>
-                <a:spcPts val="0"/>
-              </a:spcAft>
-              <a:buClrTx/>
-              <a:buSzTx/>
-              <a:buFontTx/>
-              <a:buNone/>
-              <a:tabLst/>
-              <a:defRPr/>
-            </a:pPr>
-            <a:r>
-              <a:rPr kumimoji="0" lang="en-US" sz="4800" b="0" i="0" u="none" strike="noStrike" kern="1200" cap="none" spc="0" normalizeH="0" baseline="0" noProof="0" dirty="0">
-                <a:ln>
-                  <a:noFill/>
-                </a:ln>
-                <a:solidFill>
-                  <a:prstClr val="white"/>
-                </a:solidFill>
-                <a:effectLst/>
-                <a:uLnTx/>
-                <a:uFillTx/>
-                <a:latin typeface="Aptos Display" panose="02110004020202020204"/>
-                <a:ea typeface="+mj-ea"/>
-                <a:cs typeface="+mj-cs"/>
-              </a:rPr>
-              <a:t>Summary: make the emissions known and upfront so people cannot ignore them!!!!</a:t>
+        <p:style>
+          <a:lnRef idx="2">
+            <a:schemeClr val="accent1">
+              <a:shade val="15000"/>
+            </a:schemeClr>
+          </a:lnRef>
+          <a:fillRef idx="1">
+            <a:schemeClr val="accent1"/>
+          </a:fillRef>
+          <a:effectRef idx="0">
+            <a:schemeClr val="accent1"/>
+          </a:effectRef>
+          <a:fontRef idx="minor">
+            <a:schemeClr val="lt1"/>
+          </a:fontRef>
+        </p:style>
+        <p:txBody>
+          <a:bodyPr rtlCol="0" anchor="ctr"/>
+          <a:lstStyle/>
+          <a:p>
+            <a:pPr algn="ctr"/>
+            <a:r>
+              <a:rPr lang="en-GB" sz="2800" b="1" dirty="0" err="1"/>
+              <a:t>CodeCarbon</a:t>
+            </a:r>
+            <a:r>
+              <a:rPr lang="en-GB" sz="2800" b="1" dirty="0"/>
+              <a:t> </a:t>
+            </a:r>
+            <a:r>
+              <a:rPr lang="en-GB" sz="2800" dirty="0"/>
+              <a:t>used to track the energy consumption and emissions of a Monte Carlo </a:t>
+            </a:r>
+            <a:r>
+              <a:rPr lang="en-GB" sz="2800" b="1" dirty="0"/>
+              <a:t>neutron transport simulation</a:t>
+            </a:r>
+            <a:r>
+              <a:rPr lang="en-GB" sz="2800" dirty="0"/>
+              <a:t>. </a:t>
+            </a:r>
+          </a:p>
+        </p:txBody>
+      </p:sp>
+      <p:sp>
+        <p:nvSpPr>
+          <p:cNvPr id="5" name="Rectangle: Rounded Corners 4">
+            <a:extLst>
+              <a:ext uri="{FF2B5EF4-FFF2-40B4-BE49-F238E27FC236}">
+                <a16:creationId xmlns:a16="http://schemas.microsoft.com/office/drawing/2014/main" id="{4EB23548-E3CB-9062-4B64-59B6D1182F47}"/>
+              </a:ext>
+            </a:extLst>
+          </p:cNvPr>
+          <p:cNvSpPr/>
+          <p:nvPr/>
+        </p:nvSpPr>
+        <p:spPr>
+          <a:xfrm>
+            <a:off x="6390640" y="1971040"/>
+            <a:ext cx="4307840" cy="4175760"/>
+          </a:xfrm>
+          <a:prstGeom prst="roundRect">
+            <a:avLst/>
+          </a:prstGeom>
+          <a:solidFill>
+            <a:schemeClr val="accent6">
+              <a:lumMod val="50000"/>
+            </a:schemeClr>
+          </a:solidFill>
+          <a:ln>
+            <a:noFill/>
+          </a:ln>
+        </p:spPr>
+        <p:style>
+          <a:lnRef idx="2">
+            <a:schemeClr val="accent1">
+              <a:shade val="15000"/>
+            </a:schemeClr>
+          </a:lnRef>
+          <a:fillRef idx="1">
+            <a:schemeClr val="accent1"/>
+          </a:fillRef>
+          <a:effectRef idx="0">
+            <a:schemeClr val="accent1"/>
+          </a:effectRef>
+          <a:fontRef idx="minor">
+            <a:schemeClr val="lt1"/>
+          </a:fontRef>
+        </p:style>
+        <p:txBody>
+          <a:bodyPr rtlCol="0" anchor="ctr"/>
+          <a:lstStyle/>
+          <a:p>
+            <a:pPr algn="ctr"/>
+            <a:r>
+              <a:rPr lang="en-GB" sz="2800" dirty="0"/>
+              <a:t>The resulting metrics were stored as a </a:t>
+            </a:r>
+            <a:r>
+              <a:rPr lang="en-GB" sz="2800" b="1" dirty="0"/>
+              <a:t>GreenMetaData .</a:t>
+            </a:r>
+            <a:r>
+              <a:rPr lang="en-GB" sz="2800" b="1" dirty="0" err="1"/>
+              <a:t>yml</a:t>
+            </a:r>
+            <a:r>
+              <a:rPr lang="en-GB" sz="2800" b="1" dirty="0"/>
+              <a:t> </a:t>
+            </a:r>
+            <a:r>
+              <a:rPr lang="en-GB" sz="2800" dirty="0"/>
+              <a:t>file, including the </a:t>
+            </a:r>
+            <a:r>
+              <a:rPr lang="en-GB" sz="2800" b="1" dirty="0"/>
+              <a:t>embodied</a:t>
+            </a:r>
+            <a:r>
+              <a:rPr lang="en-GB" sz="2800" dirty="0"/>
+              <a:t> carbon cost of the laptop (Lenovo ThinkPad T14 Gen 3 AMD)</a:t>
             </a:r>
           </a:p>
         </p:txBody>
@@ -5878,7 +5886,7 @@
     </p:spTree>
     <p:extLst>
       <p:ext uri="{BB962C8B-B14F-4D97-AF65-F5344CB8AC3E}">
-        <p14:creationId xmlns:p14="http://schemas.microsoft.com/office/powerpoint/2010/main" val="3727811111"/>
+        <p14:creationId xmlns:p14="http://schemas.microsoft.com/office/powerpoint/2010/main" val="1260564611"/>
       </p:ext>
     </p:extLst>
   </p:cSld>
@@ -5896,7 +5904,7 @@
         <p:cNvPr id="1" name="">
           <a:extLst>
             <a:ext uri="{FF2B5EF4-FFF2-40B4-BE49-F238E27FC236}">
-              <a16:creationId xmlns:a16="http://schemas.microsoft.com/office/drawing/2014/main" id="{C17CB6B3-619A-85FD-F2B8-E293156F2069}"/>
+              <a16:creationId xmlns:a16="http://schemas.microsoft.com/office/drawing/2014/main" id="{6E6F6A96-4B24-0581-82F8-B63EEC7D0894}"/>
             </a:ext>
           </a:extLst>
         </p:cNvPr>
@@ -5916,7 +5924,7 @@
           <p:cNvPr id="2" name="Title 1">
             <a:extLst>
               <a:ext uri="{FF2B5EF4-FFF2-40B4-BE49-F238E27FC236}">
-                <a16:creationId xmlns:a16="http://schemas.microsoft.com/office/drawing/2014/main" id="{B8CCAF32-1E81-F4E6-2BA1-E7B892654C69}"/>
+                <a16:creationId xmlns:a16="http://schemas.microsoft.com/office/drawing/2014/main" id="{6ED93FF6-4802-0549-C3D6-0F874E1B093A}"/>
               </a:ext>
             </a:extLst>
           </p:cNvPr>
@@ -5944,163 +5952,179 @@
           <a:p>
             <a:pPr algn="ctr"/>
             <a:r>
-              <a:rPr lang="en-US" sz="4800" kern="1200" dirty="0">
+              <a:rPr lang="en-US" sz="4800" dirty="0">
                 <a:solidFill>
                   <a:schemeClr val="bg1"/>
                 </a:solidFill>
-                <a:latin typeface="+mj-lt"/>
-                <a:ea typeface="+mj-ea"/>
-                <a:cs typeface="+mj-cs"/>
               </a:rPr>
-              <a:t>Part 2: Hands-On Exercise</a:t>
-            </a:r>
-          </a:p>
-        </p:txBody>
-      </p:sp>
-      <p:sp>
-        <p:nvSpPr>
-          <p:cNvPr id="4" name="Title 1">
-            <a:extLst>
-              <a:ext uri="{FF2B5EF4-FFF2-40B4-BE49-F238E27FC236}">
-                <a16:creationId xmlns:a16="http://schemas.microsoft.com/office/drawing/2014/main" id="{AB4D26F4-E1C2-9F31-5080-EFCB82DB8C54}"/>
-              </a:ext>
-            </a:extLst>
-          </p:cNvPr>
-          <p:cNvSpPr txBox="1">
-            <a:spLocks/>
-          </p:cNvSpPr>
+              <a:t>Initial Tracking Results</a:t>
+            </a:r>
+            <a:endParaRPr lang="en-US" sz="4800" kern="1200" dirty="0">
+              <a:solidFill>
+                <a:schemeClr val="bg1"/>
+              </a:solidFill>
+              <a:latin typeface="+mj-lt"/>
+              <a:ea typeface="+mj-ea"/>
+              <a:cs typeface="+mj-cs"/>
+            </a:endParaRPr>
+          </a:p>
+        </p:txBody>
+      </p:sp>
+      <p:sp>
+        <p:nvSpPr>
+          <p:cNvPr id="4" name="Rectangle: Rounded Corners 3">
+            <a:extLst>
+              <a:ext uri="{FF2B5EF4-FFF2-40B4-BE49-F238E27FC236}">
+                <a16:creationId xmlns:a16="http://schemas.microsoft.com/office/drawing/2014/main" id="{73F36CC9-D043-4064-0F4D-A493EF70CB21}"/>
+              </a:ext>
+            </a:extLst>
+          </p:cNvPr>
+          <p:cNvSpPr/>
           <p:nvPr/>
         </p:nvSpPr>
         <p:spPr>
           <a:xfrm>
-            <a:off x="816797" y="2782581"/>
-            <a:ext cx="10558405" cy="1059999"/>
+            <a:off x="934720" y="1889760"/>
+            <a:ext cx="4358640" cy="3891280"/>
           </a:xfrm>
-          <a:prstGeom prst="rect">
+          <a:prstGeom prst="roundRect">
             <a:avLst/>
           </a:prstGeom>
+          <a:solidFill>
+            <a:schemeClr val="accent6">
+              <a:lumMod val="50000"/>
+            </a:schemeClr>
+          </a:solidFill>
+          <a:ln>
+            <a:noFill/>
+          </a:ln>
         </p:spPr>
-        <p:txBody>
-          <a:bodyPr vert="horz" lIns="91440" tIns="45720" rIns="91440" bIns="45720" rtlCol="0" anchor="b">
-            <a:normAutofit fontScale="40000" lnSpcReduction="20000"/>
-          </a:bodyPr>
-          <a:lstStyle>
-            <a:lvl1pPr algn="l" defTabSz="914400" rtl="0" eaLnBrk="1" latinLnBrk="0" hangingPunct="1">
-              <a:lnSpc>
-                <a:spcPct val="90000"/>
-              </a:lnSpc>
-              <a:spcBef>
-                <a:spcPct val="0"/>
-              </a:spcBef>
-              <a:buNone/>
-              <a:defRPr sz="4400" kern="1200">
+        <p:style>
+          <a:lnRef idx="2">
+            <a:schemeClr val="accent1">
+              <a:shade val="15000"/>
+            </a:schemeClr>
+          </a:lnRef>
+          <a:fillRef idx="1">
+            <a:schemeClr val="accent1"/>
+          </a:fillRef>
+          <a:effectRef idx="0">
+            <a:schemeClr val="accent1"/>
+          </a:effectRef>
+          <a:fontRef idx="minor">
+            <a:schemeClr val="lt1"/>
+          </a:fontRef>
+        </p:style>
+        <p:txBody>
+          <a:bodyPr rtlCol="0" anchor="ctr"/>
+          <a:lstStyle/>
+          <a:p>
+            <a:pPr algn="ctr"/>
+            <a:r>
+              <a:rPr lang="en-GB" dirty="0"/>
+              <a:t>Initially, the simulation was run not in parallel, and only 1 core I </a:t>
+            </a:r>
+            <a:r>
+              <a:rPr lang="en-GB" dirty="0" err="1"/>
+              <a:t>sused</a:t>
+            </a:r>
+            <a:r>
+              <a:rPr lang="en-GB" dirty="0"/>
+              <a:t> at a time. This resulted in very long runtimes</a:t>
+            </a:r>
+          </a:p>
+        </p:txBody>
+      </p:sp>
+      <p:sp>
+        <p:nvSpPr>
+          <p:cNvPr id="6" name="Arrow: Right 5">
+            <a:extLst>
+              <a:ext uri="{FF2B5EF4-FFF2-40B4-BE49-F238E27FC236}">
+                <a16:creationId xmlns:a16="http://schemas.microsoft.com/office/drawing/2014/main" id="{2ECA9AF6-101C-3BE2-F1B8-C161D265E0C6}"/>
+              </a:ext>
+            </a:extLst>
+          </p:cNvPr>
+          <p:cNvSpPr/>
+          <p:nvPr/>
+        </p:nvSpPr>
+        <p:spPr>
+          <a:xfrm>
+            <a:off x="6096000" y="1615440"/>
+            <a:ext cx="5577840" cy="4866640"/>
+          </a:xfrm>
+          <a:prstGeom prst="rightArrow">
+            <a:avLst>
+              <a:gd name="adj1" fmla="val 76722"/>
+              <a:gd name="adj2" fmla="val 50000"/>
+            </a:avLst>
+          </a:prstGeom>
+          <a:solidFill>
+            <a:schemeClr val="accent6">
+              <a:lumMod val="20000"/>
+              <a:lumOff val="80000"/>
+            </a:schemeClr>
+          </a:solidFill>
+          <a:ln w="76200">
+            <a:solidFill>
+              <a:schemeClr val="accent6">
+                <a:lumMod val="50000"/>
+              </a:schemeClr>
+            </a:solidFill>
+          </a:ln>
+        </p:spPr>
+        <p:style>
+          <a:lnRef idx="2">
+            <a:schemeClr val="accent1">
+              <a:shade val="15000"/>
+            </a:schemeClr>
+          </a:lnRef>
+          <a:fillRef idx="1">
+            <a:schemeClr val="accent1"/>
+          </a:fillRef>
+          <a:effectRef idx="0">
+            <a:schemeClr val="accent1"/>
+          </a:effectRef>
+          <a:fontRef idx="minor">
+            <a:schemeClr val="lt1"/>
+          </a:fontRef>
+        </p:style>
+        <p:txBody>
+          <a:bodyPr rtlCol="0" anchor="ctr"/>
+          <a:lstStyle/>
+          <a:p>
+            <a:pPr algn="ctr"/>
+            <a:r>
+              <a:rPr lang="en-GB" dirty="0">
                 <a:solidFill>
-                  <a:schemeClr val="tx1"/>
+                  <a:schemeClr val="accent6">
+                    <a:lumMod val="50000"/>
+                  </a:schemeClr>
                 </a:solidFill>
-                <a:latin typeface="+mj-lt"/>
-                <a:ea typeface="+mj-ea"/>
-                <a:cs typeface="+mj-cs"/>
-              </a:defRPr>
-            </a:lvl1pPr>
-          </a:lstStyle>
-          <a:p>
-            <a:pPr marL="0" marR="0" lvl="0" indent="0" algn="l" defTabSz="914400" rtl="0" eaLnBrk="1" fontAlgn="auto" latinLnBrk="0" hangingPunct="1">
-              <a:lnSpc>
-                <a:spcPct val="90000"/>
-              </a:lnSpc>
-              <a:spcBef>
-                <a:spcPct val="0"/>
-              </a:spcBef>
-              <a:spcAft>
-                <a:spcPts val="0"/>
-              </a:spcAft>
-              <a:buClrTx/>
-              <a:buSzTx/>
-              <a:buFontTx/>
-              <a:buNone/>
-              <a:tabLst/>
-              <a:defRPr/>
-            </a:pPr>
-            <a:r>
-              <a:rPr kumimoji="0" lang="en-US" sz="4800" b="0" i="0" u="none" strike="noStrike" kern="1200" cap="none" spc="0" normalizeH="0" baseline="0" noProof="0" dirty="0">
-                <a:ln>
-                  <a:noFill/>
-                </a:ln>
+              </a:rPr>
+              <a:t>Potential Improvement using Green Software Pattern:</a:t>
+            </a:r>
+          </a:p>
+          <a:p>
+            <a:pPr algn="ctr"/>
+            <a:endParaRPr lang="en-GB" dirty="0">
+              <a:solidFill>
+                <a:schemeClr val="accent6">
+                  <a:lumMod val="50000"/>
+                </a:schemeClr>
+              </a:solidFill>
+            </a:endParaRPr>
+          </a:p>
+          <a:p>
+            <a:pPr algn="ctr"/>
+            <a:r>
+              <a:rPr lang="en-GB" dirty="0">
                 <a:solidFill>
-                  <a:prstClr val="white"/>
+                  <a:schemeClr val="accent6">
+                    <a:lumMod val="50000"/>
+                  </a:schemeClr>
                 </a:solidFill>
-                <a:effectLst/>
-                <a:uLnTx/>
-                <a:uFillTx/>
-                <a:latin typeface="Aptos Display" panose="02110004020202020204"/>
-                <a:ea typeface="+mj-ea"/>
-                <a:cs typeface="+mj-cs"/>
               </a:rPr>
-              <a:t>Big picture impact: cultural shift in research towards greener attitudes and practices.</a:t>
-            </a:r>
-          </a:p>
-          <a:p>
-            <a:pPr marL="0" marR="0" lvl="0" indent="0" algn="l" defTabSz="914400" rtl="0" eaLnBrk="1" fontAlgn="auto" latinLnBrk="0" hangingPunct="1">
-              <a:lnSpc>
-                <a:spcPct val="90000"/>
-              </a:lnSpc>
-              <a:spcBef>
-                <a:spcPct val="0"/>
-              </a:spcBef>
-              <a:spcAft>
-                <a:spcPts val="0"/>
-              </a:spcAft>
-              <a:buClrTx/>
-              <a:buSzTx/>
-              <a:buFontTx/>
-              <a:buNone/>
-              <a:tabLst/>
-              <a:defRPr/>
-            </a:pPr>
-            <a:r>
-              <a:rPr lang="en-US" sz="4800" dirty="0">
-                <a:solidFill>
-                  <a:prstClr val="white"/>
-                </a:solidFill>
-                <a:latin typeface="Aptos Display" panose="02110004020202020204"/>
-              </a:rPr>
-              <a:t>CO2 budgeting (cost benefit analysis including emissions, predicted emissions for funding applications)</a:t>
-            </a:r>
-          </a:p>
-          <a:p>
-            <a:pPr marL="0" marR="0" lvl="0" indent="0" algn="l" defTabSz="914400" rtl="0" eaLnBrk="1" fontAlgn="auto" latinLnBrk="0" hangingPunct="1">
-              <a:lnSpc>
-                <a:spcPct val="90000"/>
-              </a:lnSpc>
-              <a:spcBef>
-                <a:spcPct val="0"/>
-              </a:spcBef>
-              <a:spcAft>
-                <a:spcPts val="0"/>
-              </a:spcAft>
-              <a:buClrTx/>
-              <a:buSzTx/>
-              <a:buFontTx/>
-              <a:buNone/>
-              <a:tabLst/>
-              <a:defRPr/>
-            </a:pPr>
-            <a:r>
-              <a:rPr kumimoji="0" lang="en-US" sz="4800" b="0" i="0" u="none" strike="noStrike" kern="1200" cap="none" spc="0" normalizeH="0" baseline="0" noProof="0" dirty="0">
-                <a:ln>
-                  <a:noFill/>
-                </a:ln>
-                <a:solidFill>
-                  <a:prstClr val="white"/>
-                </a:solidFill>
-                <a:effectLst/>
-                <a:uLnTx/>
-                <a:uFillTx/>
-                <a:latin typeface="Aptos Display" panose="02110004020202020204"/>
-                <a:ea typeface="+mj-ea"/>
-                <a:cs typeface="+mj-cs"/>
-              </a:rPr>
-              <a:t>Summary: make the emissions known and upfront so people cannot ignore them!!!!</a:t>
+              <a:t>Optimise CPU utilisation by parallelising the workload, so more than 1 of the 16 threads in the CPU are occupied</a:t>
             </a:r>
           </a:p>
         </p:txBody>
@@ -6108,7 +6132,631 @@
     </p:spTree>
     <p:extLst>
       <p:ext uri="{BB962C8B-B14F-4D97-AF65-F5344CB8AC3E}">
-        <p14:creationId xmlns:p14="http://schemas.microsoft.com/office/powerpoint/2010/main" val="1260564611"/>
+        <p14:creationId xmlns:p14="http://schemas.microsoft.com/office/powerpoint/2010/main" val="3968451685"/>
+      </p:ext>
+    </p:extLst>
+  </p:cSld>
+  <p:clrMapOvr>
+    <a:masterClrMapping/>
+  </p:clrMapOvr>
+</p:sld>
+</file>
+
+<file path=ppt/slides/slide8.xml><?xml version="1.0" encoding="utf-8"?>
+<p:sld xmlns:a="http://schemas.openxmlformats.org/drawingml/2006/main" xmlns:r="http://schemas.openxmlformats.org/officeDocument/2006/relationships" xmlns:p="http://schemas.openxmlformats.org/presentationml/2006/main">
+  <p:cSld>
+    <p:spTree>
+      <p:nvGrpSpPr>
+        <p:cNvPr id="1" name="">
+          <a:extLst>
+            <a:ext uri="{FF2B5EF4-FFF2-40B4-BE49-F238E27FC236}">
+              <a16:creationId xmlns:a16="http://schemas.microsoft.com/office/drawing/2014/main" id="{D42F07AE-29E9-3605-30C6-04829D08652F}"/>
+            </a:ext>
+          </a:extLst>
+        </p:cNvPr>
+        <p:cNvGrpSpPr/>
+        <p:nvPr/>
+      </p:nvGrpSpPr>
+      <p:grpSpPr>
+        <a:xfrm>
+          <a:off x="0" y="0"/>
+          <a:ext cx="0" cy="0"/>
+          <a:chOff x="0" y="0"/>
+          <a:chExt cx="0" cy="0"/>
+        </a:xfrm>
+      </p:grpSpPr>
+      <p:sp>
+        <p:nvSpPr>
+          <p:cNvPr id="2" name="Title 1">
+            <a:extLst>
+              <a:ext uri="{FF2B5EF4-FFF2-40B4-BE49-F238E27FC236}">
+                <a16:creationId xmlns:a16="http://schemas.microsoft.com/office/drawing/2014/main" id="{B52A3803-20AD-2EB0-167A-7097B2848C4E}"/>
+              </a:ext>
+            </a:extLst>
+          </p:cNvPr>
+          <p:cNvSpPr>
+            <a:spLocks noGrp="1"/>
+          </p:cNvSpPr>
+          <p:nvPr>
+            <p:ph type="title"/>
+          </p:nvPr>
+        </p:nvSpPr>
+        <p:spPr>
+          <a:xfrm>
+            <a:off x="586508" y="280271"/>
+            <a:ext cx="10558405" cy="1059999"/>
+          </a:xfrm>
+          <a:solidFill>
+            <a:srgbClr val="7DC267"/>
+          </a:solidFill>
+        </p:spPr>
+        <p:txBody>
+          <a:bodyPr vert="horz" lIns="91440" tIns="45720" rIns="91440" bIns="45720" rtlCol="0" anchor="ctr">
+            <a:normAutofit/>
+          </a:bodyPr>
+          <a:lstStyle/>
+          <a:p>
+            <a:pPr algn="ctr"/>
+            <a:r>
+              <a:rPr lang="en-US" sz="4800" dirty="0">
+                <a:solidFill>
+                  <a:schemeClr val="bg1"/>
+                </a:solidFill>
+              </a:rPr>
+              <a:t>Parallel Computation Results</a:t>
+            </a:r>
+            <a:endParaRPr lang="en-US" sz="4800" kern="1200" dirty="0">
+              <a:solidFill>
+                <a:schemeClr val="bg1"/>
+              </a:solidFill>
+              <a:latin typeface="+mj-lt"/>
+              <a:ea typeface="+mj-ea"/>
+              <a:cs typeface="+mj-cs"/>
+            </a:endParaRPr>
+          </a:p>
+        </p:txBody>
+      </p:sp>
+      <p:sp>
+        <p:nvSpPr>
+          <p:cNvPr id="3" name="Rectangle: Rounded Corners 2">
+            <a:extLst>
+              <a:ext uri="{FF2B5EF4-FFF2-40B4-BE49-F238E27FC236}">
+                <a16:creationId xmlns:a16="http://schemas.microsoft.com/office/drawing/2014/main" id="{41BA8723-A930-6243-129A-8CD94E0CC570}"/>
+              </a:ext>
+            </a:extLst>
+          </p:cNvPr>
+          <p:cNvSpPr/>
+          <p:nvPr/>
+        </p:nvSpPr>
+        <p:spPr>
+          <a:xfrm>
+            <a:off x="1137920" y="1971040"/>
+            <a:ext cx="4307840" cy="4175760"/>
+          </a:xfrm>
+          <a:prstGeom prst="roundRect">
+            <a:avLst/>
+          </a:prstGeom>
+          <a:solidFill>
+            <a:schemeClr val="accent6">
+              <a:lumMod val="20000"/>
+              <a:lumOff val="80000"/>
+            </a:schemeClr>
+          </a:solidFill>
+          <a:ln w="76200">
+            <a:solidFill>
+              <a:schemeClr val="accent6">
+                <a:lumMod val="50000"/>
+              </a:schemeClr>
+            </a:solidFill>
+          </a:ln>
+        </p:spPr>
+        <p:style>
+          <a:lnRef idx="2">
+            <a:schemeClr val="accent1">
+              <a:shade val="15000"/>
+            </a:schemeClr>
+          </a:lnRef>
+          <a:fillRef idx="1">
+            <a:schemeClr val="accent1"/>
+          </a:fillRef>
+          <a:effectRef idx="0">
+            <a:schemeClr val="accent1"/>
+          </a:effectRef>
+          <a:fontRef idx="minor">
+            <a:schemeClr val="lt1"/>
+          </a:fontRef>
+        </p:style>
+        <p:txBody>
+          <a:bodyPr rtlCol="0" anchor="ctr"/>
+          <a:lstStyle/>
+          <a:p>
+            <a:pPr algn="ctr"/>
+            <a:r>
+              <a:rPr lang="en-GB" sz="2800" dirty="0">
+                <a:solidFill>
+                  <a:schemeClr val="accent6">
+                    <a:lumMod val="50000"/>
+                  </a:schemeClr>
+                </a:solidFill>
+              </a:rPr>
+              <a:t>CPU power draw increased…</a:t>
+            </a:r>
+          </a:p>
+          <a:p>
+            <a:pPr algn="ctr"/>
+            <a:r>
+              <a:rPr lang="en-GB" sz="4000" dirty="0">
+                <a:solidFill>
+                  <a:schemeClr val="accent6">
+                    <a:lumMod val="50000"/>
+                  </a:schemeClr>
+                </a:solidFill>
+              </a:rPr>
+              <a:t>But </a:t>
+            </a:r>
+            <a:r>
+              <a:rPr lang="en-GB" sz="4000" b="1" dirty="0">
+                <a:solidFill>
+                  <a:schemeClr val="accent6">
+                    <a:lumMod val="50000"/>
+                  </a:schemeClr>
+                </a:solidFill>
+              </a:rPr>
+              <a:t>run-times plummeted</a:t>
+            </a:r>
+            <a:r>
+              <a:rPr lang="en-GB" sz="3200" dirty="0">
+                <a:solidFill>
+                  <a:schemeClr val="accent6">
+                    <a:lumMod val="50000"/>
+                  </a:schemeClr>
+                </a:solidFill>
+              </a:rPr>
+              <a:t>. </a:t>
+            </a:r>
+          </a:p>
+          <a:p>
+            <a:pPr algn="ctr"/>
+            <a:endParaRPr lang="en-GB" dirty="0">
+              <a:solidFill>
+                <a:schemeClr val="accent6">
+                  <a:lumMod val="50000"/>
+                </a:schemeClr>
+              </a:solidFill>
+            </a:endParaRPr>
+          </a:p>
+          <a:p>
+            <a:pPr algn="ctr"/>
+            <a:r>
+              <a:rPr lang="en-GB" sz="2800" dirty="0">
+                <a:solidFill>
+                  <a:schemeClr val="accent6">
+                    <a:lumMod val="50000"/>
+                  </a:schemeClr>
+                </a:solidFill>
+              </a:rPr>
+              <a:t>Computational idle time is reduced and energy efficiency is improved.</a:t>
+            </a:r>
+          </a:p>
+        </p:txBody>
+      </p:sp>
+      <p:sp>
+        <p:nvSpPr>
+          <p:cNvPr id="5" name="Rectangle: Rounded Corners 4">
+            <a:extLst>
+              <a:ext uri="{FF2B5EF4-FFF2-40B4-BE49-F238E27FC236}">
+                <a16:creationId xmlns:a16="http://schemas.microsoft.com/office/drawing/2014/main" id="{609831FE-4FD8-A7BB-AFE0-9B25599234D3}"/>
+              </a:ext>
+            </a:extLst>
+          </p:cNvPr>
+          <p:cNvSpPr/>
+          <p:nvPr/>
+        </p:nvSpPr>
+        <p:spPr>
+          <a:xfrm>
+            <a:off x="6390640" y="1971040"/>
+            <a:ext cx="4307840" cy="4175760"/>
+          </a:xfrm>
+          <a:prstGeom prst="roundRect">
+            <a:avLst/>
+          </a:prstGeom>
+          <a:solidFill>
+            <a:schemeClr val="accent6">
+              <a:lumMod val="20000"/>
+              <a:lumOff val="80000"/>
+            </a:schemeClr>
+          </a:solidFill>
+          <a:ln w="76200">
+            <a:solidFill>
+              <a:schemeClr val="accent6">
+                <a:lumMod val="50000"/>
+              </a:schemeClr>
+            </a:solidFill>
+          </a:ln>
+        </p:spPr>
+        <p:style>
+          <a:lnRef idx="2">
+            <a:schemeClr val="accent1">
+              <a:shade val="15000"/>
+            </a:schemeClr>
+          </a:lnRef>
+          <a:fillRef idx="1">
+            <a:schemeClr val="accent1"/>
+          </a:fillRef>
+          <a:effectRef idx="0">
+            <a:schemeClr val="accent1"/>
+          </a:effectRef>
+          <a:fontRef idx="minor">
+            <a:schemeClr val="lt1"/>
+          </a:fontRef>
+        </p:style>
+        <p:txBody>
+          <a:bodyPr rtlCol="0" anchor="ctr"/>
+          <a:lstStyle/>
+          <a:p>
+            <a:pPr algn="ctr"/>
+            <a:r>
+              <a:rPr lang="en-GB" sz="3600" dirty="0">
+                <a:solidFill>
+                  <a:schemeClr val="accent6">
+                    <a:lumMod val="50000"/>
+                  </a:schemeClr>
+                </a:solidFill>
+              </a:rPr>
+              <a:t>Total energy consumption is </a:t>
+            </a:r>
+            <a:r>
+              <a:rPr lang="en-GB" sz="4000" b="1" dirty="0">
+                <a:solidFill>
+                  <a:schemeClr val="accent6">
+                    <a:lumMod val="50000"/>
+                  </a:schemeClr>
+                </a:solidFill>
+              </a:rPr>
+              <a:t>halved</a:t>
+            </a:r>
+            <a:r>
+              <a:rPr lang="en-GB" sz="4000" dirty="0">
+                <a:solidFill>
+                  <a:schemeClr val="accent6">
+                    <a:lumMod val="50000"/>
+                  </a:schemeClr>
+                </a:solidFill>
+              </a:rPr>
+              <a:t>!</a:t>
+            </a:r>
+          </a:p>
+          <a:p>
+            <a:pPr algn="ctr"/>
+            <a:r>
+              <a:rPr lang="en-GB" sz="2400" dirty="0">
+                <a:solidFill>
+                  <a:schemeClr val="accent6">
+                    <a:lumMod val="50000"/>
+                  </a:schemeClr>
+                </a:solidFill>
+              </a:rPr>
+              <a:t>Initial energy consumption: </a:t>
+            </a:r>
+            <a:r>
+              <a:rPr lang="en-GB" sz="2800" b="1" dirty="0">
+                <a:solidFill>
+                  <a:schemeClr val="accent6">
+                    <a:lumMod val="50000"/>
+                  </a:schemeClr>
+                </a:solidFill>
+              </a:rPr>
+              <a:t>0.0040 kWh</a:t>
+            </a:r>
+          </a:p>
+          <a:p>
+            <a:pPr algn="ctr"/>
+            <a:r>
+              <a:rPr lang="en-GB" sz="2400" dirty="0">
+                <a:solidFill>
+                  <a:schemeClr val="accent6">
+                    <a:lumMod val="50000"/>
+                  </a:schemeClr>
+                </a:solidFill>
+              </a:rPr>
+              <a:t>Parallelised energy consumption: </a:t>
+            </a:r>
+          </a:p>
+          <a:p>
+            <a:pPr algn="ctr"/>
+            <a:r>
+              <a:rPr lang="en-GB" sz="2800" b="1" dirty="0">
+                <a:solidFill>
+                  <a:schemeClr val="accent6">
+                    <a:lumMod val="50000"/>
+                  </a:schemeClr>
+                </a:solidFill>
+              </a:rPr>
+              <a:t>0.0019 kWh</a:t>
+            </a:r>
+          </a:p>
+          <a:p>
+            <a:pPr algn="ctr"/>
+            <a:endParaRPr lang="en-GB" dirty="0"/>
+          </a:p>
+        </p:txBody>
+      </p:sp>
+    </p:spTree>
+    <p:extLst>
+      <p:ext uri="{BB962C8B-B14F-4D97-AF65-F5344CB8AC3E}">
+        <p14:creationId xmlns:p14="http://schemas.microsoft.com/office/powerpoint/2010/main" val="1035102672"/>
+      </p:ext>
+    </p:extLst>
+  </p:cSld>
+  <p:clrMapOvr>
+    <a:masterClrMapping/>
+  </p:clrMapOvr>
+</p:sld>
+</file>
+
+<file path=ppt/slides/slide9.xml><?xml version="1.0" encoding="utf-8"?>
+<p:sld xmlns:a="http://schemas.openxmlformats.org/drawingml/2006/main" xmlns:r="http://schemas.openxmlformats.org/officeDocument/2006/relationships" xmlns:p="http://schemas.openxmlformats.org/presentationml/2006/main">
+  <p:cSld>
+    <p:spTree>
+      <p:nvGrpSpPr>
+        <p:cNvPr id="1" name="">
+          <a:extLst>
+            <a:ext uri="{FF2B5EF4-FFF2-40B4-BE49-F238E27FC236}">
+              <a16:creationId xmlns:a16="http://schemas.microsoft.com/office/drawing/2014/main" id="{69D42646-1EF9-FEF4-1566-B7DEA0DAF4CE}"/>
+            </a:ext>
+          </a:extLst>
+        </p:cNvPr>
+        <p:cNvGrpSpPr/>
+        <p:nvPr/>
+      </p:nvGrpSpPr>
+      <p:grpSpPr>
+        <a:xfrm>
+          <a:off x="0" y="0"/>
+          <a:ext cx="0" cy="0"/>
+          <a:chOff x="0" y="0"/>
+          <a:chExt cx="0" cy="0"/>
+        </a:xfrm>
+      </p:grpSpPr>
+      <p:sp>
+        <p:nvSpPr>
+          <p:cNvPr id="2" name="Title 1">
+            <a:extLst>
+              <a:ext uri="{FF2B5EF4-FFF2-40B4-BE49-F238E27FC236}">
+                <a16:creationId xmlns:a16="http://schemas.microsoft.com/office/drawing/2014/main" id="{64C4BC38-381B-091B-A8EC-2291D91A1A34}"/>
+              </a:ext>
+            </a:extLst>
+          </p:cNvPr>
+          <p:cNvSpPr>
+            <a:spLocks noGrp="1"/>
+          </p:cNvSpPr>
+          <p:nvPr>
+            <p:ph type="title"/>
+          </p:nvPr>
+        </p:nvSpPr>
+        <p:spPr>
+          <a:xfrm>
+            <a:off x="586508" y="280271"/>
+            <a:ext cx="10558405" cy="1059999"/>
+          </a:xfrm>
+          <a:solidFill>
+            <a:srgbClr val="7DC267"/>
+          </a:solidFill>
+        </p:spPr>
+        <p:txBody>
+          <a:bodyPr vert="horz" lIns="91440" tIns="45720" rIns="91440" bIns="45720" rtlCol="0" anchor="ctr">
+            <a:normAutofit/>
+          </a:bodyPr>
+          <a:lstStyle/>
+          <a:p>
+            <a:pPr algn="ctr"/>
+            <a:r>
+              <a:rPr lang="en-US" sz="4800" dirty="0">
+                <a:solidFill>
+                  <a:schemeClr val="bg1"/>
+                </a:solidFill>
+              </a:rPr>
+              <a:t>Wider Impacts</a:t>
+            </a:r>
+            <a:endParaRPr lang="en-US" sz="4800" kern="1200" dirty="0">
+              <a:solidFill>
+                <a:schemeClr val="bg1"/>
+              </a:solidFill>
+              <a:latin typeface="+mj-lt"/>
+              <a:ea typeface="+mj-ea"/>
+              <a:cs typeface="+mj-cs"/>
+            </a:endParaRPr>
+          </a:p>
+        </p:txBody>
+      </p:sp>
+      <p:sp>
+        <p:nvSpPr>
+          <p:cNvPr id="3" name="Rectangle: Rounded Corners 2">
+            <a:extLst>
+              <a:ext uri="{FF2B5EF4-FFF2-40B4-BE49-F238E27FC236}">
+                <a16:creationId xmlns:a16="http://schemas.microsoft.com/office/drawing/2014/main" id="{7687E877-E83A-80A0-A5A4-2B370F6CBB8B}"/>
+              </a:ext>
+            </a:extLst>
+          </p:cNvPr>
+          <p:cNvSpPr/>
+          <p:nvPr/>
+        </p:nvSpPr>
+        <p:spPr>
+          <a:xfrm>
+            <a:off x="1137920" y="1971040"/>
+            <a:ext cx="4307840" cy="4175760"/>
+          </a:xfrm>
+          <a:prstGeom prst="roundRect">
+            <a:avLst/>
+          </a:prstGeom>
+          <a:solidFill>
+            <a:schemeClr val="accent6">
+              <a:lumMod val="20000"/>
+              <a:lumOff val="80000"/>
+            </a:schemeClr>
+          </a:solidFill>
+          <a:ln w="76200">
+            <a:solidFill>
+              <a:schemeClr val="accent6">
+                <a:lumMod val="50000"/>
+              </a:schemeClr>
+            </a:solidFill>
+          </a:ln>
+        </p:spPr>
+        <p:style>
+          <a:lnRef idx="2">
+            <a:schemeClr val="accent1">
+              <a:shade val="15000"/>
+            </a:schemeClr>
+          </a:lnRef>
+          <a:fillRef idx="1">
+            <a:schemeClr val="accent1"/>
+          </a:fillRef>
+          <a:effectRef idx="0">
+            <a:schemeClr val="accent1"/>
+          </a:effectRef>
+          <a:fontRef idx="minor">
+            <a:schemeClr val="lt1"/>
+          </a:fontRef>
+        </p:style>
+        <p:txBody>
+          <a:bodyPr rtlCol="0" anchor="ctr"/>
+          <a:lstStyle/>
+          <a:p>
+            <a:pPr algn="ctr"/>
+            <a:r>
+              <a:rPr lang="en-GB" sz="2800" dirty="0">
+                <a:solidFill>
+                  <a:schemeClr val="accent6">
+                    <a:lumMod val="50000"/>
+                  </a:schemeClr>
+                </a:solidFill>
+              </a:rPr>
+              <a:t>Increasing CPU utilisation may not always increase energy efficiency.</a:t>
+            </a:r>
+          </a:p>
+          <a:p>
+            <a:pPr algn="ctr"/>
+            <a:r>
+              <a:rPr lang="en-GB" sz="2800" dirty="0">
+                <a:solidFill>
+                  <a:schemeClr val="accent6">
+                    <a:lumMod val="50000"/>
+                  </a:schemeClr>
+                </a:solidFill>
+              </a:rPr>
+              <a:t>The key idea is average CPU utilisation (green software pattern)</a:t>
+            </a:r>
+          </a:p>
+          <a:p>
+            <a:pPr algn="ctr"/>
+            <a:r>
+              <a:rPr lang="en-GB" sz="1200" dirty="0">
+                <a:hlinkClick r:id="rId2"/>
+              </a:rPr>
+              <a:t>Optimize average CPU utilization | Green Software Patterns</a:t>
+            </a:r>
+            <a:endParaRPr lang="en-GB" sz="1200" dirty="0">
+              <a:solidFill>
+                <a:schemeClr val="accent6">
+                  <a:lumMod val="50000"/>
+                </a:schemeClr>
+              </a:solidFill>
+            </a:endParaRPr>
+          </a:p>
+        </p:txBody>
+      </p:sp>
+      <p:sp>
+        <p:nvSpPr>
+          <p:cNvPr id="5" name="Rectangle: Rounded Corners 4">
+            <a:extLst>
+              <a:ext uri="{FF2B5EF4-FFF2-40B4-BE49-F238E27FC236}">
+                <a16:creationId xmlns:a16="http://schemas.microsoft.com/office/drawing/2014/main" id="{12694B25-8BB2-BEB2-9788-1B7BE20E4420}"/>
+              </a:ext>
+            </a:extLst>
+          </p:cNvPr>
+          <p:cNvSpPr/>
+          <p:nvPr/>
+        </p:nvSpPr>
+        <p:spPr>
+          <a:xfrm>
+            <a:off x="6390640" y="1971040"/>
+            <a:ext cx="4307840" cy="4175760"/>
+          </a:xfrm>
+          <a:prstGeom prst="roundRect">
+            <a:avLst/>
+          </a:prstGeom>
+          <a:solidFill>
+            <a:schemeClr val="accent6">
+              <a:lumMod val="20000"/>
+              <a:lumOff val="80000"/>
+            </a:schemeClr>
+          </a:solidFill>
+          <a:ln w="76200">
+            <a:solidFill>
+              <a:schemeClr val="accent6">
+                <a:lumMod val="50000"/>
+              </a:schemeClr>
+            </a:solidFill>
+          </a:ln>
+        </p:spPr>
+        <p:style>
+          <a:lnRef idx="2">
+            <a:schemeClr val="accent1">
+              <a:shade val="15000"/>
+            </a:schemeClr>
+          </a:lnRef>
+          <a:fillRef idx="1">
+            <a:schemeClr val="accent1"/>
+          </a:fillRef>
+          <a:effectRef idx="0">
+            <a:schemeClr val="accent1"/>
+          </a:effectRef>
+          <a:fontRef idx="minor">
+            <a:schemeClr val="lt1"/>
+          </a:fontRef>
+        </p:style>
+        <p:txBody>
+          <a:bodyPr rtlCol="0" anchor="ctr"/>
+          <a:lstStyle/>
+          <a:p>
+            <a:pPr algn="ctr"/>
+            <a:r>
+              <a:rPr lang="en-GB" dirty="0">
+                <a:solidFill>
+                  <a:schemeClr val="accent6">
+                    <a:lumMod val="50000"/>
+                  </a:schemeClr>
+                </a:solidFill>
+              </a:rPr>
+              <a:t>Goal</a:t>
+            </a:r>
+            <a:r>
+              <a:rPr lang="en-GB">
+                <a:solidFill>
+                  <a:schemeClr val="accent6">
+                    <a:lumMod val="50000"/>
+                  </a:schemeClr>
+                </a:solidFill>
+              </a:rPr>
+              <a:t>: minimise large </a:t>
+            </a:r>
+            <a:r>
+              <a:rPr lang="en-GB" dirty="0">
+                <a:solidFill>
+                  <a:schemeClr val="accent6">
+                    <a:lumMod val="50000"/>
+                  </a:schemeClr>
+                </a:solidFill>
+              </a:rPr>
+              <a:t>fluctuations in CPU load</a:t>
+            </a:r>
+          </a:p>
+        </p:txBody>
+      </p:sp>
+    </p:spTree>
+    <p:extLst>
+      <p:ext uri="{BB962C8B-B14F-4D97-AF65-F5344CB8AC3E}">
+        <p14:creationId xmlns:p14="http://schemas.microsoft.com/office/powerpoint/2010/main" val="1370249691"/>
       </p:ext>
     </p:extLst>
   </p:cSld>

</xml_diff>

<commit_message>
edits and finishing touches to part 2
</commit_message>
<xml_diff>
--- a/GSoC – GreenMetaData Project.pptx
+++ b/GSoC – GreenMetaData Project.pptx
@@ -5789,7 +5789,7 @@
             </a:r>
             <a:r>
               <a:rPr lang="en-GB" sz="2800" dirty="0"/>
-              <a:t>used to track the energy consumption and emissions of a Monte Carlo </a:t>
+              <a:t>was used to track the energy consumption and emissions of a Monte Carlo </a:t>
             </a:r>
             <a:r>
               <a:rPr lang="en-GB" sz="2800" b="1" dirty="0"/>
@@ -5984,8 +5984,8 @@
         </p:nvSpPr>
         <p:spPr>
           <a:xfrm>
-            <a:off x="934720" y="1889760"/>
-            <a:ext cx="4358640" cy="3891280"/>
+            <a:off x="375920" y="1889760"/>
+            <a:ext cx="5039360" cy="3891280"/>
           </a:xfrm>
           <a:prstGeom prst="roundRect">
             <a:avLst/>
@@ -6021,16 +6021,94 @@
           <a:p>
             <a:pPr algn="ctr"/>
             <a:r>
-              <a:rPr lang="en-GB" dirty="0"/>
-              <a:t>Initially, the simulation was run not in parallel, and only 1 core I </a:t>
-            </a:r>
-            <a:r>
-              <a:rPr lang="en-GB" dirty="0" err="1"/>
-              <a:t>sused</a:t>
-            </a:r>
-            <a:r>
-              <a:rPr lang="en-GB" dirty="0"/>
-              <a:t> at a time. This resulted in very long runtimes</a:t>
+              <a:rPr lang="en-GB" sz="2400" dirty="0"/>
+              <a:t>Simulation was running </a:t>
+            </a:r>
+            <a:r>
+              <a:rPr lang="en-GB" sz="2400" b="1" dirty="0"/>
+              <a:t>sequentially</a:t>
+            </a:r>
+            <a:r>
+              <a:rPr lang="en-GB" sz="2400" dirty="0"/>
+              <a:t> with a maximum of </a:t>
+            </a:r>
+            <a:r>
+              <a:rPr lang="en-GB" sz="2400" b="1" dirty="0"/>
+              <a:t>1</a:t>
+            </a:r>
+            <a:r>
+              <a:rPr lang="en-GB" sz="2400" dirty="0"/>
+              <a:t> thread active at any time. This resulted in: </a:t>
+            </a:r>
+          </a:p>
+          <a:p>
+            <a:pPr marL="285750" indent="-285750" algn="ctr">
+              <a:buFont typeface="Arial" panose="020B0604020202020204" pitchFamily="34" charset="0"/>
+              <a:buChar char="•"/>
+            </a:pPr>
+            <a:r>
+              <a:rPr lang="en-GB" sz="2800" b="1" dirty="0"/>
+              <a:t>Low</a:t>
+            </a:r>
+            <a:r>
+              <a:rPr lang="en-GB" sz="2800" dirty="0"/>
+              <a:t> CPU</a:t>
+            </a:r>
+            <a:r>
+              <a:rPr lang="en-GB" sz="2800" b="1" dirty="0"/>
+              <a:t> utilisation </a:t>
+            </a:r>
+            <a:r>
+              <a:rPr lang="en-GB" sz="2800" dirty="0"/>
+              <a:t>(~6%)</a:t>
+            </a:r>
+            <a:endParaRPr lang="en-GB" sz="2800" b="1" dirty="0"/>
+          </a:p>
+          <a:p>
+            <a:pPr marL="285750" indent="-285750" algn="ctr">
+              <a:buFont typeface="Arial" panose="020B0604020202020204" pitchFamily="34" charset="0"/>
+              <a:buChar char="•"/>
+            </a:pPr>
+            <a:r>
+              <a:rPr lang="en-GB" sz="2800" b="1" dirty="0"/>
+              <a:t>Low</a:t>
+            </a:r>
+            <a:r>
+              <a:rPr lang="en-GB" sz="2800" dirty="0"/>
+              <a:t> CPU </a:t>
+            </a:r>
+            <a:r>
+              <a:rPr lang="en-GB" sz="2800" b="1" dirty="0"/>
+              <a:t>power draw </a:t>
+            </a:r>
+            <a:r>
+              <a:rPr lang="en-GB" sz="2800" dirty="0"/>
+              <a:t>(~1W)</a:t>
+            </a:r>
+          </a:p>
+          <a:p>
+            <a:pPr marL="285750" indent="-285750" algn="ctr">
+              <a:buFont typeface="Arial" panose="020B0604020202020204" pitchFamily="34" charset="0"/>
+              <a:buChar char="•"/>
+            </a:pPr>
+            <a:r>
+              <a:rPr lang="en-GB" sz="2800" dirty="0"/>
+              <a:t>Total </a:t>
+            </a:r>
+            <a:r>
+              <a:rPr lang="en-GB" sz="2800" b="1" dirty="0"/>
+              <a:t>emissions</a:t>
+            </a:r>
+            <a:r>
+              <a:rPr lang="en-GB" sz="2800" dirty="0"/>
+              <a:t>: </a:t>
+            </a:r>
+            <a:br>
+              <a:rPr lang="en-GB" sz="2800" dirty="0"/>
+            </a:br>
+            <a:r>
+              <a:rPr lang="en-GB" sz="2800" b="1" dirty="0"/>
+              <a:t>0.95 gCO2e</a:t>
             </a:r>
           </a:p>
         </p:txBody>
@@ -6049,8 +6127,8 @@
         </p:nvSpPr>
         <p:spPr>
           <a:xfrm>
-            <a:off x="6096000" y="1615440"/>
-            <a:ext cx="5577840" cy="4866640"/>
+            <a:off x="5709920" y="1381190"/>
+            <a:ext cx="6228080" cy="4866640"/>
           </a:xfrm>
           <a:prstGeom prst="rightArrow">
             <a:avLst>
@@ -6093,19 +6171,6 @@
           <a:lstStyle/>
           <a:p>
             <a:pPr algn="ctr"/>
-            <a:r>
-              <a:rPr lang="en-GB" dirty="0">
-                <a:solidFill>
-                  <a:schemeClr val="accent6">
-                    <a:lumMod val="50000"/>
-                  </a:schemeClr>
-                </a:solidFill>
-              </a:rPr>
-              <a:t>Potential Improvement using Green Software Pattern:</a:t>
-            </a:r>
-          </a:p>
-          <a:p>
-            <a:pPr algn="ctr"/>
             <a:endParaRPr lang="en-GB" dirty="0">
               <a:solidFill>
                 <a:schemeClr val="accent6">
@@ -6114,21 +6179,245 @@
               </a:solidFill>
             </a:endParaRPr>
           </a:p>
-          <a:p>
-            <a:pPr algn="ctr"/>
-            <a:r>
-              <a:rPr lang="en-GB" dirty="0">
+        </p:txBody>
+      </p:sp>
+      <p:sp>
+        <p:nvSpPr>
+          <p:cNvPr id="7" name="Rectangle 6">
+            <a:extLst>
+              <a:ext uri="{FF2B5EF4-FFF2-40B4-BE49-F238E27FC236}">
+                <a16:creationId xmlns:a16="http://schemas.microsoft.com/office/drawing/2014/main" id="{FDD0444A-E4B8-CF03-4B48-B6E2A686E066}"/>
+              </a:ext>
+            </a:extLst>
+          </p:cNvPr>
+          <p:cNvSpPr/>
+          <p:nvPr/>
+        </p:nvSpPr>
+        <p:spPr>
+          <a:xfrm>
+            <a:off x="5709920" y="2183830"/>
+            <a:ext cx="5781040" cy="3261360"/>
+          </a:xfrm>
+          <a:prstGeom prst="rect">
+            <a:avLst/>
+          </a:prstGeom>
+          <a:noFill/>
+          <a:ln>
+            <a:noFill/>
+          </a:ln>
+        </p:spPr>
+        <p:style>
+          <a:lnRef idx="2">
+            <a:schemeClr val="accent1">
+              <a:shade val="15000"/>
+            </a:schemeClr>
+          </a:lnRef>
+          <a:fillRef idx="1">
+            <a:schemeClr val="accent1"/>
+          </a:fillRef>
+          <a:effectRef idx="0">
+            <a:schemeClr val="accent1"/>
+          </a:effectRef>
+          <a:fontRef idx="minor">
+            <a:schemeClr val="lt1"/>
+          </a:fontRef>
+        </p:style>
+        <p:txBody>
+          <a:bodyPr rtlCol="0" anchor="ctr"/>
+          <a:lstStyle/>
+          <a:p>
+            <a:r>
+              <a:rPr lang="en-GB" sz="2800" dirty="0">
                 <a:solidFill>
                   <a:schemeClr val="accent6">
                     <a:lumMod val="50000"/>
                   </a:schemeClr>
                 </a:solidFill>
               </a:rPr>
-              <a:t>Optimise CPU utilisation by parallelising the workload, so more than 1 of the 16 threads in the CPU are occupied</a:t>
-            </a:r>
-          </a:p>
-        </p:txBody>
-      </p:sp>
+              <a:t>Reducing environmental        </a:t>
+            </a:r>
+            <a:br>
+              <a:rPr lang="en-GB" sz="2800" dirty="0">
+                <a:solidFill>
+                  <a:schemeClr val="accent6">
+                    <a:lumMod val="50000"/>
+                  </a:schemeClr>
+                </a:solidFill>
+              </a:rPr>
+            </a:br>
+            <a:r>
+              <a:rPr lang="en-GB" sz="2800" dirty="0">
+                <a:solidFill>
+                  <a:schemeClr val="accent6">
+                    <a:lumMod val="50000"/>
+                  </a:schemeClr>
+                </a:solidFill>
+              </a:rPr>
+              <a:t>impact via green software </a:t>
+            </a:r>
+            <a:br>
+              <a:rPr lang="en-GB" sz="2800" dirty="0">
+                <a:solidFill>
+                  <a:schemeClr val="accent6">
+                    <a:lumMod val="50000"/>
+                  </a:schemeClr>
+                </a:solidFill>
+              </a:rPr>
+            </a:br>
+            <a:r>
+              <a:rPr lang="en-GB" sz="2800" dirty="0">
+                <a:solidFill>
+                  <a:schemeClr val="accent6">
+                    <a:lumMod val="50000"/>
+                  </a:schemeClr>
+                </a:solidFill>
+              </a:rPr>
+              <a:t>patterns:</a:t>
+            </a:r>
+          </a:p>
+          <a:p>
+            <a:pPr algn="ctr"/>
+            <a:endParaRPr lang="en-GB" sz="800" dirty="0">
+              <a:solidFill>
+                <a:schemeClr val="accent6">
+                  <a:lumMod val="50000"/>
+                </a:schemeClr>
+              </a:solidFill>
+            </a:endParaRPr>
+          </a:p>
+          <a:p>
+            <a:r>
+              <a:rPr lang="en-GB" sz="3600" b="1" dirty="0">
+                <a:solidFill>
+                  <a:schemeClr val="accent6">
+                    <a:lumMod val="50000"/>
+                  </a:schemeClr>
+                </a:solidFill>
+              </a:rPr>
+              <a:t>Optimising CPU utilisation </a:t>
+            </a:r>
+          </a:p>
+          <a:p>
+            <a:pPr algn="ctr"/>
+            <a:endParaRPr lang="en-GB" sz="800" b="1" dirty="0">
+              <a:solidFill>
+                <a:schemeClr val="accent6">
+                  <a:lumMod val="50000"/>
+                </a:schemeClr>
+              </a:solidFill>
+            </a:endParaRPr>
+          </a:p>
+          <a:p>
+            <a:r>
+              <a:rPr lang="en-GB" sz="2800" dirty="0">
+                <a:solidFill>
+                  <a:schemeClr val="accent6">
+                    <a:lumMod val="50000"/>
+                  </a:schemeClr>
+                </a:solidFill>
+              </a:rPr>
+              <a:t>By </a:t>
+            </a:r>
+            <a:r>
+              <a:rPr lang="en-GB" sz="2800" b="1" dirty="0">
+                <a:solidFill>
+                  <a:schemeClr val="accent6">
+                    <a:lumMod val="50000"/>
+                  </a:schemeClr>
+                </a:solidFill>
+              </a:rPr>
+              <a:t>parallelising</a:t>
+            </a:r>
+            <a:r>
+              <a:rPr lang="en-GB" sz="2800" dirty="0">
+                <a:solidFill>
+                  <a:schemeClr val="accent6">
+                    <a:lumMod val="50000"/>
+                  </a:schemeClr>
+                </a:solidFill>
+              </a:rPr>
+              <a:t> the workflow, multiple tasks can run </a:t>
+            </a:r>
+            <a:r>
+              <a:rPr lang="en-GB" sz="2800" b="1" dirty="0">
+                <a:solidFill>
+                  <a:schemeClr val="accent6">
+                    <a:lumMod val="50000"/>
+                  </a:schemeClr>
+                </a:solidFill>
+              </a:rPr>
+              <a:t>simultaneously</a:t>
+            </a:r>
+            <a:endParaRPr lang="en-GB" b="1" dirty="0">
+              <a:solidFill>
+                <a:schemeClr val="accent6">
+                  <a:lumMod val="50000"/>
+                </a:schemeClr>
+              </a:solidFill>
+            </a:endParaRPr>
+          </a:p>
+        </p:txBody>
+      </p:sp>
+      <p:pic>
+        <p:nvPicPr>
+          <p:cNvPr id="9" name="Picture 8">
+            <a:extLst>
+              <a:ext uri="{FF2B5EF4-FFF2-40B4-BE49-F238E27FC236}">
+                <a16:creationId xmlns:a16="http://schemas.microsoft.com/office/drawing/2014/main" id="{8C709A41-C45F-1714-23B2-8771EEC8D334}"/>
+              </a:ext>
+            </a:extLst>
+          </p:cNvPr>
+          <p:cNvPicPr>
+            <a:picLocks noChangeAspect="1"/>
+          </p:cNvPicPr>
+          <p:nvPr/>
+        </p:nvPicPr>
+        <p:blipFill>
+          <a:blip r:embed="rId2"/>
+          <a:stretch>
+            <a:fillRect/>
+          </a:stretch>
+        </p:blipFill>
+        <p:spPr>
+          <a:xfrm>
+            <a:off x="247230" y="5314250"/>
+            <a:ext cx="1562318" cy="933580"/>
+          </a:xfrm>
+          <a:prstGeom prst="rect">
+            <a:avLst/>
+          </a:prstGeom>
+        </p:spPr>
+      </p:pic>
+      <p:pic>
+        <p:nvPicPr>
+          <p:cNvPr id="11" name="Picture 10">
+            <a:extLst>
+              <a:ext uri="{FF2B5EF4-FFF2-40B4-BE49-F238E27FC236}">
+                <a16:creationId xmlns:a16="http://schemas.microsoft.com/office/drawing/2014/main" id="{53147B85-500E-713B-2AF4-D1E6D98B382E}"/>
+              </a:ext>
+            </a:extLst>
+          </p:cNvPr>
+          <p:cNvPicPr>
+            <a:picLocks noChangeAspect="1"/>
+          </p:cNvPicPr>
+          <p:nvPr/>
+        </p:nvPicPr>
+        <p:blipFill>
+          <a:blip r:embed="rId3"/>
+          <a:stretch>
+            <a:fillRect/>
+          </a:stretch>
+        </p:blipFill>
+        <p:spPr>
+          <a:xfrm>
+            <a:off x="8616748" y="1709450"/>
+            <a:ext cx="3199332" cy="360619"/>
+          </a:xfrm>
+          <a:prstGeom prst="rect">
+            <a:avLst/>
+          </a:prstGeom>
+        </p:spPr>
+      </p:pic>
     </p:spTree>
     <p:extLst>
       <p:ext uri="{BB962C8B-B14F-4D97-AF65-F5344CB8AC3E}">
@@ -6335,7 +6624,37 @@
                   </a:schemeClr>
                 </a:solidFill>
               </a:rPr>
-              <a:t>Computational idle time is reduced and energy efficiency is improved.</a:t>
+              <a:t>Computational idle time is </a:t>
+            </a:r>
+            <a:r>
+              <a:rPr lang="en-GB" sz="2800" b="1" dirty="0">
+                <a:solidFill>
+                  <a:schemeClr val="accent6">
+                    <a:lumMod val="50000"/>
+                  </a:schemeClr>
+                </a:solidFill>
+              </a:rPr>
+              <a:t>reduced </a:t>
+            </a:r>
+            <a:r>
+              <a:rPr lang="en-GB" sz="2800" dirty="0">
+                <a:solidFill>
+                  <a:schemeClr val="accent6">
+                    <a:lumMod val="50000"/>
+                  </a:schemeClr>
+                </a:solidFill>
+              </a:rPr>
+              <a:t>and energy efficiency is </a:t>
+            </a:r>
+            <a:r>
+              <a:rPr lang="en-GB" sz="2800" b="1" dirty="0">
+                <a:solidFill>
+                  <a:schemeClr val="accent6">
+                    <a:lumMod val="50000"/>
+                  </a:schemeClr>
+                </a:solidFill>
+              </a:rPr>
+              <a:t>improved.</a:t>
             </a:r>
           </a:p>
         </p:txBody>
@@ -6481,6 +6800,36 @@
           </a:p>
         </p:txBody>
       </p:sp>
+      <p:pic>
+        <p:nvPicPr>
+          <p:cNvPr id="4" name="Picture 3">
+            <a:extLst>
+              <a:ext uri="{FF2B5EF4-FFF2-40B4-BE49-F238E27FC236}">
+                <a16:creationId xmlns:a16="http://schemas.microsoft.com/office/drawing/2014/main" id="{4D3F6E71-3A8B-5D5A-AFAF-028A643F3D8E}"/>
+              </a:ext>
+            </a:extLst>
+          </p:cNvPr>
+          <p:cNvPicPr>
+            <a:picLocks noChangeAspect="1"/>
+          </p:cNvPicPr>
+          <p:nvPr/>
+        </p:nvPicPr>
+        <p:blipFill>
+          <a:blip r:embed="rId2"/>
+          <a:stretch>
+            <a:fillRect/>
+          </a:stretch>
+        </p:blipFill>
+        <p:spPr>
+          <a:xfrm>
+            <a:off x="10081042" y="5456490"/>
+            <a:ext cx="1562318" cy="933580"/>
+          </a:xfrm>
+          <a:prstGeom prst="rect">
+            <a:avLst/>
+          </a:prstGeom>
+        </p:spPr>
+      </p:pic>
     </p:spTree>
     <p:extLst>
       <p:ext uri="{BB962C8B-B14F-4D97-AF65-F5344CB8AC3E}">
@@ -6555,7 +6904,7 @@
                   <a:schemeClr val="bg1"/>
                 </a:solidFill>
               </a:rPr>
-              <a:t>Wider Impacts</a:t>
+              <a:t>Wider Implications</a:t>
             </a:r>
             <a:endParaRPr lang="en-US" sz="4800" kern="1200" dirty="0">
               <a:solidFill>
@@ -6582,8 +6931,8 @@
         </p:nvSpPr>
         <p:spPr>
           <a:xfrm>
-            <a:off x="1137920" y="1971040"/>
-            <a:ext cx="4307840" cy="4175760"/>
+            <a:off x="484458" y="1671320"/>
+            <a:ext cx="3953727" cy="4719444"/>
           </a:xfrm>
           <a:prstGeom prst="roundRect">
             <a:avLst/>
@@ -6631,21 +6980,78 @@
                   </a:schemeClr>
                 </a:solidFill>
               </a:rPr>
-              <a:t>Increasing CPU utilisation may not always increase energy efficiency.</a:t>
-            </a:r>
-          </a:p>
-          <a:p>
-            <a:pPr algn="ctr"/>
-            <a:r>
-              <a:rPr lang="en-GB" sz="2800" dirty="0">
+              <a:t>Increasing CPU utilisation may </a:t>
+            </a:r>
+            <a:r>
+              <a:rPr lang="en-GB" sz="2800" b="1" dirty="0">
                 <a:solidFill>
                   <a:schemeClr val="accent6">
                     <a:lumMod val="50000"/>
                   </a:schemeClr>
                 </a:solidFill>
               </a:rPr>
-              <a:t>The key idea is average CPU utilisation (green software pattern)</a:t>
-            </a:r>
+              <a:t>not</a:t>
+            </a:r>
+            <a:r>
+              <a:rPr lang="en-GB" sz="2800" dirty="0">
+                <a:solidFill>
+                  <a:schemeClr val="accent6">
+                    <a:lumMod val="50000"/>
+                  </a:schemeClr>
+                </a:solidFill>
+              </a:rPr>
+              <a:t> always increase </a:t>
+            </a:r>
+            <a:r>
+              <a:rPr lang="en-GB" sz="2800" b="1" dirty="0">
+                <a:solidFill>
+                  <a:schemeClr val="accent6">
+                    <a:lumMod val="50000"/>
+                  </a:schemeClr>
+                </a:solidFill>
+              </a:rPr>
+              <a:t>energy efficiency.</a:t>
+            </a:r>
+          </a:p>
+          <a:p>
+            <a:pPr algn="ctr"/>
+            <a:endParaRPr lang="en-GB" sz="600" dirty="0">
+              <a:solidFill>
+                <a:schemeClr val="accent6">
+                  <a:lumMod val="50000"/>
+                </a:schemeClr>
+              </a:solidFill>
+            </a:endParaRPr>
+          </a:p>
+          <a:p>
+            <a:pPr algn="ctr"/>
+            <a:r>
+              <a:rPr lang="en-GB" sz="3200" dirty="0">
+                <a:solidFill>
+                  <a:schemeClr val="accent6">
+                    <a:lumMod val="50000"/>
+                  </a:schemeClr>
+                </a:solidFill>
+              </a:rPr>
+              <a:t>The key idea is </a:t>
+            </a:r>
+            <a:r>
+              <a:rPr lang="en-GB" sz="4000" b="1" dirty="0">
+                <a:solidFill>
+                  <a:schemeClr val="accent6">
+                    <a:lumMod val="50000"/>
+                  </a:schemeClr>
+                </a:solidFill>
+              </a:rPr>
+              <a:t>Optimising Average CPU Utilisation.</a:t>
+            </a:r>
+            <a:endParaRPr lang="en-GB" sz="3200" b="1" dirty="0">
+              <a:solidFill>
+                <a:schemeClr val="accent6">
+                  <a:lumMod val="50000"/>
+                </a:schemeClr>
+              </a:solidFill>
+            </a:endParaRPr>
           </a:p>
           <a:p>
             <a:pPr algn="ctr"/>
@@ -6679,8 +7085,8 @@
         </p:nvSpPr>
         <p:spPr>
           <a:xfrm>
-            <a:off x="6390640" y="1971040"/>
-            <a:ext cx="4307840" cy="4175760"/>
+            <a:off x="5080000" y="1671320"/>
+            <a:ext cx="6807200" cy="1630680"/>
           </a:xfrm>
           <a:prstGeom prst="roundRect">
             <a:avLst/>
@@ -6716,12 +7122,12 @@
           </a:fontRef>
         </p:style>
         <p:txBody>
-          <a:bodyPr rtlCol="0" anchor="ctr"/>
+          <a:bodyPr rtlCol="0" anchor="t"/>
           <a:lstStyle/>
           <a:p>
             <a:pPr algn="ctr"/>
             <a:r>
-              <a:rPr lang="en-GB" dirty="0">
+              <a:rPr lang="en-GB" sz="3200" b="1" u="sng" dirty="0">
                 <a:solidFill>
                   <a:schemeClr val="accent6">
                     <a:lumMod val="50000"/>
@@ -6731,25 +7137,162 @@
               <a:t>Goal</a:t>
             </a:r>
             <a:r>
-              <a:rPr lang="en-GB">
+              <a:rPr lang="en-GB" sz="3200" dirty="0">
                 <a:solidFill>
                   <a:schemeClr val="accent6">
                     <a:lumMod val="50000"/>
                   </a:schemeClr>
                 </a:solidFill>
               </a:rPr>
-              <a:t>: minimise large </a:t>
-            </a:r>
-            <a:r>
-              <a:rPr lang="en-GB" dirty="0">
+              <a:t>: </a:t>
+            </a:r>
+            <a:r>
+              <a:rPr lang="en-GB" sz="2800" dirty="0">
                 <a:solidFill>
                   <a:schemeClr val="accent6">
                     <a:lumMod val="50000"/>
                   </a:schemeClr>
                 </a:solidFill>
               </a:rPr>
-              <a:t>fluctuations in CPU load</a:t>
-            </a:r>
+              <a:t>Minimise large </a:t>
+            </a:r>
+            <a:r>
+              <a:rPr lang="en-GB" sz="2800" b="1" dirty="0">
+                <a:solidFill>
+                  <a:schemeClr val="accent6">
+                    <a:lumMod val="50000"/>
+                  </a:schemeClr>
+                </a:solidFill>
+              </a:rPr>
+              <a:t>fluctuations</a:t>
+            </a:r>
+            <a:r>
+              <a:rPr lang="en-GB" sz="2800" dirty="0">
+                <a:solidFill>
+                  <a:schemeClr val="accent6">
+                    <a:lumMod val="50000"/>
+                  </a:schemeClr>
+                </a:solidFill>
+              </a:rPr>
+              <a:t> in CPU load, to reduce </a:t>
+            </a:r>
+            <a:r>
+              <a:rPr lang="en-GB" sz="2800" b="1" dirty="0">
+                <a:solidFill>
+                  <a:schemeClr val="accent6">
+                    <a:lumMod val="50000"/>
+                  </a:schemeClr>
+                </a:solidFill>
+              </a:rPr>
+              <a:t>excessive</a:t>
+            </a:r>
+            <a:r>
+              <a:rPr lang="en-GB" sz="2800" dirty="0">
+                <a:solidFill>
+                  <a:schemeClr val="accent6">
+                    <a:lumMod val="50000"/>
+                  </a:schemeClr>
+                </a:solidFill>
+              </a:rPr>
+              <a:t> resources that are under-utilised/ on stand-by.</a:t>
+            </a:r>
+          </a:p>
+        </p:txBody>
+      </p:sp>
+      <p:pic>
+        <p:nvPicPr>
+          <p:cNvPr id="3076" name="Picture 4">
+            <a:extLst>
+              <a:ext uri="{FF2B5EF4-FFF2-40B4-BE49-F238E27FC236}">
+                <a16:creationId xmlns:a16="http://schemas.microsoft.com/office/drawing/2014/main" id="{C7050096-FE7C-D58B-8B87-40A5686E119F}"/>
+              </a:ext>
+            </a:extLst>
+          </p:cNvPr>
+          <p:cNvPicPr>
+            <a:picLocks noChangeAspect="1" noChangeArrowheads="1"/>
+          </p:cNvPicPr>
+          <p:nvPr/>
+        </p:nvPicPr>
+        <p:blipFill>
+          <a:blip r:embed="rId3">
+            <a:extLst>
+              <a:ext uri="{28A0092B-C50C-407E-A947-70E740481C1C}">
+                <a14:useLocalDpi xmlns:a14="http://schemas.microsoft.com/office/drawing/2010/main" val="0"/>
+              </a:ext>
+            </a:extLst>
+          </a:blip>
+          <a:srcRect/>
+          <a:stretch>
+            <a:fillRect/>
+          </a:stretch>
+        </p:blipFill>
+        <p:spPr bwMode="auto">
+          <a:xfrm>
+            <a:off x="6898005" y="3452272"/>
+            <a:ext cx="3171189" cy="3171189"/>
+          </a:xfrm>
+          <a:prstGeom prst="rect">
+            <a:avLst/>
+          </a:prstGeom>
+          <a:noFill/>
+          <a:extLst>
+            <a:ext uri="{909E8E84-426E-40DD-AFC4-6F175D3DCCD1}">
+              <a14:hiddenFill xmlns:a14="http://schemas.microsoft.com/office/drawing/2010/main">
+                <a:solidFill>
+                  <a:srgbClr val="FFFFFF"/>
+                </a:solidFill>
+              </a14:hiddenFill>
+            </a:ext>
+          </a:extLst>
+        </p:spPr>
+      </p:pic>
+      <p:sp>
+        <p:nvSpPr>
+          <p:cNvPr id="4" name="TextBox 3">
+            <a:extLst>
+              <a:ext uri="{FF2B5EF4-FFF2-40B4-BE49-F238E27FC236}">
+                <a16:creationId xmlns:a16="http://schemas.microsoft.com/office/drawing/2014/main" id="{41591BA6-ECB2-3118-5A36-4BC53258336D}"/>
+              </a:ext>
+            </a:extLst>
+          </p:cNvPr>
+          <p:cNvSpPr txBox="1"/>
+          <p:nvPr/>
+        </p:nvSpPr>
+        <p:spPr>
+          <a:xfrm>
+            <a:off x="7118363" y="6604456"/>
+            <a:ext cx="2730471" cy="169277"/>
+          </a:xfrm>
+          <a:prstGeom prst="rect">
+            <a:avLst/>
+          </a:prstGeom>
+          <a:noFill/>
+        </p:spPr>
+        <p:txBody>
+          <a:bodyPr wrap="square" rtlCol="0">
+            <a:spAutoFit/>
+          </a:bodyPr>
+          <a:lstStyle/>
+          <a:p>
+            <a:r>
+              <a:rPr lang="en-GB" sz="500" dirty="0">
+                <a:hlinkClick r:id="rId4"/>
+              </a:rPr>
+              <a:t>PHP Tricks That Slash CPU Spikes in Production | by Asian Digital Hub | </a:t>
+            </a:r>
+            <a:r>
+              <a:rPr lang="en-GB" sz="500" dirty="0" err="1">
+                <a:hlinkClick r:id="rId4"/>
+              </a:rPr>
+              <a:t>DevSphere</a:t>
+            </a:r>
+            <a:r>
+              <a:rPr lang="en-GB" sz="500" dirty="0">
+                <a:hlinkClick r:id="rId4"/>
+              </a:rPr>
+              <a:t> | Medium</a:t>
+            </a:r>
+            <a:endParaRPr lang="en-GB" sz="500" dirty="0"/>
           </a:p>
         </p:txBody>
       </p:sp>

</xml_diff>